<commit_message>
fix: protect bottom-right logo safe zone
</commit_message>
<xml_diff>
--- a/assets/templates/inspur-pragmatic-template-v1.pptx
+++ b/assets/templates/inspur-pragmatic-template-v1.pptx
@@ -8904,7 +8904,7 @@
         </p:nvGraphicFramePr>
         <p:xfrm>
           <a:off x="767408" y="908720"/>
-          <a:ext cx="10369152" cy="5476427"/>
+          <a:ext cx="8700000" cy="4700000"/>
         </p:xfrm>
         <a:graphic>
           <a:graphicData uri="http://schemas.openxmlformats.org/drawingml/2006/table">
@@ -8913,28 +8913,28 @@
                 <a:tableStyleId>{21E4AEA4-8DFA-4A89-87EB-49C32662AFE0}</a:tableStyleId>
               </a:tblPr>
               <a:tblGrid>
-                <a:gridCol w="1342767">
+                <a:gridCol w="1126618">
                   <a:extLst>
                     <a:ext uri="{9D8B030D-6E8A-4147-A177-3AD203B41FA5}">
                       <a16:colId xmlns:a16="http://schemas.microsoft.com/office/drawing/2014/main" val="20000"/>
                     </a:ext>
                   </a:extLst>
                 </a:gridCol>
-                <a:gridCol w="2014152">
+                <a:gridCol w="1689928">
                   <a:extLst>
                     <a:ext uri="{9D8B030D-6E8A-4147-A177-3AD203B41FA5}">
                       <a16:colId xmlns:a16="http://schemas.microsoft.com/office/drawing/2014/main" val="20001"/>
                     </a:ext>
                   </a:extLst>
                 </a:gridCol>
-                <a:gridCol w="3655312">
+                <a:gridCol w="3066906">
                   <a:extLst>
                     <a:ext uri="{9D8B030D-6E8A-4147-A177-3AD203B41FA5}">
                       <a16:colId xmlns:a16="http://schemas.microsoft.com/office/drawing/2014/main" val="20002"/>
                     </a:ext>
                   </a:extLst>
                 </a:gridCol>
-                <a:gridCol w="3356921">
+                <a:gridCol w="2816548">
                   <a:extLst>
                     <a:ext uri="{9D8B030D-6E8A-4147-A177-3AD203B41FA5}">
                       <a16:colId xmlns:a16="http://schemas.microsoft.com/office/drawing/2014/main" val="20003"/>
@@ -8942,7 +8942,7 @@
                   </a:extLst>
                 </a:gridCol>
               </a:tblGrid>
-              <a:tr h="391400">
+              <a:tr h="335908">
                 <a:tc gridSpan="2">
                   <a:txBody>
                     <a:bodyPr/>
@@ -8997,7 +8997,7 @@
                   </a:ext>
                 </a:extLst>
               </a:tr>
-              <a:tr h="190817">
+              <a:tr h="163763">
                 <a:tc rowSpan="3">
                   <a:txBody>
                     <a:bodyPr/>
@@ -9052,7 +9052,7 @@
                   </a:ext>
                 </a:extLst>
               </a:tr>
-              <a:tr h="190817">
+              <a:tr h="163763">
                 <a:tc vMerge="1">
                   <a:txBody>
                     <a:bodyPr/>
@@ -9107,7 +9107,7 @@
                   </a:ext>
                 </a:extLst>
               </a:tr>
-              <a:tr h="190817">
+              <a:tr h="163763">
                 <a:tc vMerge="1">
                   <a:txBody>
                     <a:bodyPr/>
@@ -9162,7 +9162,7 @@
                   </a:ext>
                 </a:extLst>
               </a:tr>
-              <a:tr h="257269">
+              <a:tr h="220794">
                 <a:tc rowSpan="7">
                   <a:txBody>
                     <a:bodyPr/>
@@ -9217,7 +9217,7 @@
                   </a:ext>
                 </a:extLst>
               </a:tr>
-              <a:tr h="190817">
+              <a:tr h="163763">
                 <a:tc vMerge="1">
                   <a:txBody>
                     <a:bodyPr/>
@@ -9272,7 +9272,7 @@
                   </a:ext>
                 </a:extLst>
               </a:tr>
-              <a:tr h="190817">
+              <a:tr h="163763">
                 <a:tc vMerge="1">
                   <a:txBody>
                     <a:bodyPr/>
@@ -9327,7 +9327,7 @@
                   </a:ext>
                 </a:extLst>
               </a:tr>
-              <a:tr h="190817">
+              <a:tr h="163763">
                 <a:tc vMerge="1">
                   <a:txBody>
                     <a:bodyPr/>
@@ -9366,7 +9366,7 @@
                   </a:ext>
                 </a:extLst>
               </a:tr>
-              <a:tr h="190817">
+              <a:tr h="163763">
                 <a:tc vMerge="1">
                   <a:txBody>
                     <a:bodyPr/>
@@ -9405,7 +9405,7 @@
                   </a:ext>
                 </a:extLst>
               </a:tr>
-              <a:tr h="247436">
+              <a:tr h="212356">
                 <a:tc vMerge="1">
                   <a:txBody>
                     <a:bodyPr/>
@@ -9444,7 +9444,7 @@
                   </a:ext>
                 </a:extLst>
               </a:tr>
-              <a:tr h="190817">
+              <a:tr h="163763">
                 <a:tc vMerge="1">
                   <a:txBody>
                     <a:bodyPr/>
@@ -9483,7 +9483,7 @@
                   </a:ext>
                 </a:extLst>
               </a:tr>
-              <a:tr h="190817">
+              <a:tr h="163763">
                 <a:tc rowSpan="5">
                   <a:txBody>
                     <a:bodyPr/>
@@ -9522,7 +9522,7 @@
                   </a:ext>
                 </a:extLst>
               </a:tr>
-              <a:tr h="190817">
+              <a:tr h="163763">
                 <a:tc vMerge="1">
                   <a:txBody>
                     <a:bodyPr/>
@@ -9561,7 +9561,7 @@
                   </a:ext>
                 </a:extLst>
               </a:tr>
-              <a:tr h="190817">
+              <a:tr h="163763">
                 <a:tc vMerge="1">
                   <a:txBody>
                     <a:bodyPr/>
@@ -9600,7 +9600,7 @@
                   </a:ext>
                 </a:extLst>
               </a:tr>
-              <a:tr h="190817">
+              <a:tr h="163763">
                 <a:tc vMerge="1">
                   <a:txBody>
                     <a:bodyPr/>
@@ -9639,7 +9639,7 @@
                   </a:ext>
                 </a:extLst>
               </a:tr>
-              <a:tr h="190817">
+              <a:tr h="163763">
                 <a:tc vMerge="1">
                   <a:txBody>
                     <a:bodyPr/>
@@ -9678,7 +9678,7 @@
                   </a:ext>
                 </a:extLst>
               </a:tr>
-              <a:tr h="190817">
+              <a:tr h="163763">
                 <a:tc rowSpan="4">
                   <a:txBody>
                     <a:bodyPr/>
@@ -9717,7 +9717,7 @@
                   </a:ext>
                 </a:extLst>
               </a:tr>
-              <a:tr h="190817">
+              <a:tr h="163763">
                 <a:tc vMerge="1">
                   <a:txBody>
                     <a:bodyPr/>
@@ -9756,7 +9756,7 @@
                   </a:ext>
                 </a:extLst>
               </a:tr>
-              <a:tr h="190817">
+              <a:tr h="163763">
                 <a:tc vMerge="1">
                   <a:txBody>
                     <a:bodyPr/>
@@ -9795,7 +9795,7 @@
                   </a:ext>
                 </a:extLst>
               </a:tr>
-              <a:tr h="190817">
+              <a:tr h="163763">
                 <a:tc vMerge="1">
                   <a:txBody>
                     <a:bodyPr/>
@@ -9834,7 +9834,7 @@
                   </a:ext>
                 </a:extLst>
               </a:tr>
-              <a:tr h="190817">
+              <a:tr h="163763">
                 <a:tc rowSpan="5">
                   <a:txBody>
                     <a:bodyPr/>
@@ -9873,7 +9873,7 @@
                   </a:ext>
                 </a:extLst>
               </a:tr>
-              <a:tr h="190817">
+              <a:tr h="163763">
                 <a:tc vMerge="1">
                   <a:txBody>
                     <a:bodyPr/>
@@ -9912,7 +9912,7 @@
                   </a:ext>
                 </a:extLst>
               </a:tr>
-              <a:tr h="190817">
+              <a:tr h="163763">
                 <a:tc vMerge="1">
                   <a:txBody>
                     <a:bodyPr/>
@@ -9951,7 +9951,7 @@
                   </a:ext>
                 </a:extLst>
               </a:tr>
-              <a:tr h="190817">
+              <a:tr h="163763">
                 <a:tc vMerge="1">
                   <a:txBody>
                     <a:bodyPr/>
@@ -9990,7 +9990,7 @@
                   </a:ext>
                 </a:extLst>
               </a:tr>
-              <a:tr h="190817">
+              <a:tr h="491919">
                 <a:tc vMerge="1">
                   <a:txBody>
                     <a:bodyPr/>
@@ -10442,7 +10442,7 @@
         </p:nvSpPr>
         <p:spPr>
           <a:xfrm>
-            <a:off x="5591944" y="3861048"/>
+            <a:off x="4900000" y="3493847"/>
             <a:ext cx="686435" cy="401955"/>
           </a:xfrm>
           <a:prstGeom prst="rightArrow">
@@ -10491,7 +10491,7 @@
         <p:spPr>
           <a:xfrm>
             <a:off x="983433" y="1844824"/>
-            <a:ext cx="4104456" cy="4546356"/>
+            <a:ext cx="3600000" cy="3700000"/>
           </a:xfrm>
           <a:prstGeom prst="rect">
             <a:avLst/>
@@ -10544,8 +10544,8 @@
         </p:nvSpPr>
         <p:spPr>
           <a:xfrm>
-            <a:off x="6816080" y="1844824"/>
-            <a:ext cx="4185373" cy="4546356"/>
+            <a:off x="5900000" y="1844824"/>
+            <a:ext cx="3600000" cy="3700000"/>
           </a:xfrm>
           <a:prstGeom prst="rect">
             <a:avLst/>

</xml_diff>

<commit_message>
fix: avoid redundant cover white panels
</commit_message>
<xml_diff>
--- a/assets/templates/inspur-pragmatic-template-v1.pptx
+++ b/assets/templates/inspur-pragmatic-template-v1.pptx
@@ -1606,7 +1606,7 @@
 </file>
 
 <file path=ppt/slideLayouts/slideLayout1.xml><?xml version="1.0" encoding="utf-8"?>
-<p:sldLayout xmlns:a="http://schemas.openxmlformats.org/drawingml/2006/main" xmlns:r="http://schemas.openxmlformats.org/officeDocument/2006/relationships" xmlns:p="http://schemas.openxmlformats.org/presentationml/2006/main" showMasterSp="0" preserve="1" userDrawn="1">
+<p:sldLayout xmlns:a="http://schemas.openxmlformats.org/drawingml/2006/main" xmlns:ns3="http://schemas.microsoft.com/office/drawing/2010/main" xmlns:p="http://schemas.openxmlformats.org/presentationml/2006/main" xmlns:r="http://schemas.openxmlformats.org/officeDocument/2006/relationships" showMasterSp="0" preserve="1" userDrawn="1">
   <p:cSld name="标题幻灯片">
     <p:spTree>
       <p:nvGrpSpPr>
@@ -1662,127 +1662,6 @@
       </p:sp>
       <p:sp>
         <p:nvSpPr>
-          <p:cNvPr id="5" name="Freeform 14"/>
-          <p:cNvSpPr/>
-          <p:nvPr userDrawn="1"/>
-        </p:nvSpPr>
-        <p:spPr bwMode="auto">
-          <a:xfrm>
-            <a:off x="0" y="4695825"/>
-            <a:ext cx="12202584" cy="2189163"/>
-          </a:xfrm>
-          <a:custGeom>
-            <a:avLst/>
-            <a:gdLst>
-              <a:gd name="connsiteX0" fmla="*/ 9997 w 10000"/>
-              <a:gd name="connsiteY0" fmla="*/ 10000 h 10000"/>
-              <a:gd name="connsiteX1" fmla="*/ 3 w 10000"/>
-              <a:gd name="connsiteY1" fmla="*/ 9274 h 10000"/>
-              <a:gd name="connsiteX2" fmla="*/ 0 w 10000"/>
-              <a:gd name="connsiteY2" fmla="*/ 2434 h 10000"/>
-              <a:gd name="connsiteX3" fmla="*/ 2435 w 10000"/>
-              <a:gd name="connsiteY3" fmla="*/ 2408 h 10000"/>
-              <a:gd name="connsiteX4" fmla="*/ 3056 w 10000"/>
-              <a:gd name="connsiteY4" fmla="*/ 0 h 10000"/>
-              <a:gd name="connsiteX5" fmla="*/ 10000 w 10000"/>
-              <a:gd name="connsiteY5" fmla="*/ 7 h 10000"/>
-              <a:gd name="connsiteX6" fmla="*/ 9997 w 10000"/>
-              <a:gd name="connsiteY6" fmla="*/ 10000 h 10000"/>
-              <a:gd name="connsiteX0-1" fmla="*/ 9996 w 10000"/>
-              <a:gd name="connsiteY0-2" fmla="*/ 9274 h 9274"/>
-              <a:gd name="connsiteX1-3" fmla="*/ 3 w 10000"/>
-              <a:gd name="connsiteY1-4" fmla="*/ 9274 h 9274"/>
-              <a:gd name="connsiteX2-5" fmla="*/ 0 w 10000"/>
-              <a:gd name="connsiteY2-6" fmla="*/ 2434 h 9274"/>
-              <a:gd name="connsiteX3-7" fmla="*/ 2435 w 10000"/>
-              <a:gd name="connsiteY3-8" fmla="*/ 2408 h 9274"/>
-              <a:gd name="connsiteX4-9" fmla="*/ 3056 w 10000"/>
-              <a:gd name="connsiteY4-10" fmla="*/ 0 h 9274"/>
-              <a:gd name="connsiteX5-11" fmla="*/ 10000 w 10000"/>
-              <a:gd name="connsiteY5-12" fmla="*/ 7 h 9274"/>
-              <a:gd name="connsiteX6-13" fmla="*/ 9996 w 10000"/>
-              <a:gd name="connsiteY6-14" fmla="*/ 9274 h 9274"/>
-            </a:gdLst>
-            <a:ahLst/>
-            <a:cxnLst>
-              <a:cxn ang="0">
-                <a:pos x="connsiteX0-1" y="connsiteY0-2"/>
-              </a:cxn>
-              <a:cxn ang="0">
-                <a:pos x="connsiteX1-3" y="connsiteY1-4"/>
-              </a:cxn>
-              <a:cxn ang="0">
-                <a:pos x="connsiteX2-5" y="connsiteY2-6"/>
-              </a:cxn>
-              <a:cxn ang="0">
-                <a:pos x="connsiteX3-7" y="connsiteY3-8"/>
-              </a:cxn>
-              <a:cxn ang="0">
-                <a:pos x="connsiteX4-9" y="connsiteY4-10"/>
-              </a:cxn>
-              <a:cxn ang="0">
-                <a:pos x="connsiteX5-11" y="connsiteY5-12"/>
-              </a:cxn>
-              <a:cxn ang="0">
-                <a:pos x="connsiteX6-13" y="connsiteY6-14"/>
-              </a:cxn>
-            </a:cxnLst>
-            <a:rect l="l" t="t" r="r" b="b"/>
-            <a:pathLst>
-              <a:path w="10000" h="9274">
-                <a:moveTo>
-                  <a:pt x="9996" y="9274"/>
-                </a:moveTo>
-                <a:lnTo>
-                  <a:pt x="3" y="9274"/>
-                </a:lnTo>
-                <a:cubicBezTo>
-                  <a:pt x="1" y="6752"/>
-                  <a:pt x="2" y="4956"/>
-                  <a:pt x="0" y="2434"/>
-                </a:cubicBezTo>
-                <a:lnTo>
-                  <a:pt x="2435" y="2408"/>
-                </a:lnTo>
-                <a:lnTo>
-                  <a:pt x="3056" y="0"/>
-                </a:lnTo>
-                <a:lnTo>
-                  <a:pt x="10000" y="7"/>
-                </a:lnTo>
-                <a:cubicBezTo>
-                  <a:pt x="9999" y="3096"/>
-                  <a:pt x="9997" y="6185"/>
-                  <a:pt x="9996" y="9274"/>
-                </a:cubicBezTo>
-                <a:close/>
-              </a:path>
-            </a:pathLst>
-          </a:custGeom>
-          <a:solidFill>
-            <a:schemeClr val="bg1"/>
-          </a:solidFill>
-          <a:ln w="9525">
-            <a:noFill/>
-            <a:round/>
-          </a:ln>
-          <a:effectLst/>
-        </p:spPr>
-        <p:txBody>
-          <a:bodyPr/>
-          <a:lstStyle/>
-          <a:p>
-            <a:pPr>
-              <a:defRPr/>
-            </a:pPr>
-            <a:endParaRPr lang="zh-CN" altLang="en-US">
-              <a:latin typeface="Arial" panose="020B0604020202020204" pitchFamily="34" charset="0"/>
-            </a:endParaRPr>
-          </a:p>
-        </p:txBody>
-      </p:sp>
-      <p:sp>
-        <p:nvSpPr>
           <p:cNvPr id="6" name="Rectangle 11"/>
           <p:cNvSpPr>
             <a:spLocks noChangeArrowheads="1"/>
@@ -1831,7 +1710,7 @@
           <a:blip r:embed="rId2">
             <a:extLst>
               <a:ext uri="{28A0092B-C50C-407E-A947-70E740481C1C}">
-                <a14:useLocalDpi xmlns:a14="http://schemas.microsoft.com/office/drawing/2010/main" val="0"/>
+                <ns3:useLocalDpi val="0"/>
               </a:ext>
             </a:extLst>
           </a:blip>
@@ -1854,21 +1733,21 @@
           </a:ln>
           <a:extLst>
             <a:ext uri="{909E8E84-426E-40DD-AFC4-6F175D3DCCD1}">
-              <a14:hiddenFill xmlns:a14="http://schemas.microsoft.com/office/drawing/2010/main">
+              <ns3:hiddenFill>
                 <a:solidFill>
                   <a:srgbClr val="FFFFFF"/>
                 </a:solidFill>
-              </a14:hiddenFill>
+              </ns3:hiddenFill>
             </a:ext>
             <a:ext uri="{91240B29-F687-4F45-9708-019B960494DF}">
-              <a14:hiddenLine xmlns:a14="http://schemas.microsoft.com/office/drawing/2010/main" w="9525">
+              <ns3:hiddenLine w="9525">
                 <a:solidFill>
                   <a:srgbClr val="000000"/>
                 </a:solidFill>
                 <a:miter lim="800000"/>
                 <a:headEnd/>
                 <a:tailEnd/>
-              </a14:hiddenLine>
+              </ns3:hiddenLine>
             </a:ext>
           </a:extLst>
         </p:spPr>
@@ -2308,7 +2187,7 @@
 </file>
 
 <file path=ppt/slideLayouts/slideLayout13.xml><?xml version="1.0" encoding="utf-8"?>
-<p:sldLayout xmlns:a="http://schemas.openxmlformats.org/drawingml/2006/main" xmlns:r="http://schemas.openxmlformats.org/officeDocument/2006/relationships" xmlns:p="http://schemas.openxmlformats.org/presentationml/2006/main" showMasterSp="0" preserve="1" userDrawn="1">
+<p:sldLayout xmlns:a="http://schemas.openxmlformats.org/drawingml/2006/main" xmlns:ns3="http://schemas.microsoft.com/office/drawing/2010/main" xmlns:p="http://schemas.openxmlformats.org/presentationml/2006/main" xmlns:r="http://schemas.openxmlformats.org/officeDocument/2006/relationships" showMasterSp="0" preserve="1" userDrawn="1">
   <p:cSld name="标题幻灯片">
     <p:spTree>
       <p:nvGrpSpPr>
@@ -2407,127 +2286,6 @@
       </p:sp>
       <p:sp>
         <p:nvSpPr>
-          <p:cNvPr id="5" name="Freeform 14"/>
-          <p:cNvSpPr/>
-          <p:nvPr userDrawn="1"/>
-        </p:nvSpPr>
-        <p:spPr bwMode="auto">
-          <a:xfrm>
-            <a:off x="0" y="4695825"/>
-            <a:ext cx="12202584" cy="2189163"/>
-          </a:xfrm>
-          <a:custGeom>
-            <a:avLst/>
-            <a:gdLst>
-              <a:gd name="connsiteX0" fmla="*/ 9997 w 10000"/>
-              <a:gd name="connsiteY0" fmla="*/ 10000 h 10000"/>
-              <a:gd name="connsiteX1" fmla="*/ 3 w 10000"/>
-              <a:gd name="connsiteY1" fmla="*/ 9274 h 10000"/>
-              <a:gd name="connsiteX2" fmla="*/ 0 w 10000"/>
-              <a:gd name="connsiteY2" fmla="*/ 2434 h 10000"/>
-              <a:gd name="connsiteX3" fmla="*/ 2435 w 10000"/>
-              <a:gd name="connsiteY3" fmla="*/ 2408 h 10000"/>
-              <a:gd name="connsiteX4" fmla="*/ 3056 w 10000"/>
-              <a:gd name="connsiteY4" fmla="*/ 0 h 10000"/>
-              <a:gd name="connsiteX5" fmla="*/ 10000 w 10000"/>
-              <a:gd name="connsiteY5" fmla="*/ 7 h 10000"/>
-              <a:gd name="connsiteX6" fmla="*/ 9997 w 10000"/>
-              <a:gd name="connsiteY6" fmla="*/ 10000 h 10000"/>
-              <a:gd name="connsiteX0-1" fmla="*/ 9996 w 10000"/>
-              <a:gd name="connsiteY0-2" fmla="*/ 9274 h 9274"/>
-              <a:gd name="connsiteX1-3" fmla="*/ 3 w 10000"/>
-              <a:gd name="connsiteY1-4" fmla="*/ 9274 h 9274"/>
-              <a:gd name="connsiteX2-5" fmla="*/ 0 w 10000"/>
-              <a:gd name="connsiteY2-6" fmla="*/ 2434 h 9274"/>
-              <a:gd name="connsiteX3-7" fmla="*/ 2435 w 10000"/>
-              <a:gd name="connsiteY3-8" fmla="*/ 2408 h 9274"/>
-              <a:gd name="connsiteX4-9" fmla="*/ 3056 w 10000"/>
-              <a:gd name="connsiteY4-10" fmla="*/ 0 h 9274"/>
-              <a:gd name="connsiteX5-11" fmla="*/ 10000 w 10000"/>
-              <a:gd name="connsiteY5-12" fmla="*/ 7 h 9274"/>
-              <a:gd name="connsiteX6-13" fmla="*/ 9996 w 10000"/>
-              <a:gd name="connsiteY6-14" fmla="*/ 9274 h 9274"/>
-            </a:gdLst>
-            <a:ahLst/>
-            <a:cxnLst>
-              <a:cxn ang="0">
-                <a:pos x="connsiteX0-1" y="connsiteY0-2"/>
-              </a:cxn>
-              <a:cxn ang="0">
-                <a:pos x="connsiteX1-3" y="connsiteY1-4"/>
-              </a:cxn>
-              <a:cxn ang="0">
-                <a:pos x="connsiteX2-5" y="connsiteY2-6"/>
-              </a:cxn>
-              <a:cxn ang="0">
-                <a:pos x="connsiteX3-7" y="connsiteY3-8"/>
-              </a:cxn>
-              <a:cxn ang="0">
-                <a:pos x="connsiteX4-9" y="connsiteY4-10"/>
-              </a:cxn>
-              <a:cxn ang="0">
-                <a:pos x="connsiteX5-11" y="connsiteY5-12"/>
-              </a:cxn>
-              <a:cxn ang="0">
-                <a:pos x="connsiteX6-13" y="connsiteY6-14"/>
-              </a:cxn>
-            </a:cxnLst>
-            <a:rect l="l" t="t" r="r" b="b"/>
-            <a:pathLst>
-              <a:path w="10000" h="9274">
-                <a:moveTo>
-                  <a:pt x="9996" y="9274"/>
-                </a:moveTo>
-                <a:lnTo>
-                  <a:pt x="3" y="9274"/>
-                </a:lnTo>
-                <a:cubicBezTo>
-                  <a:pt x="1" y="6752"/>
-                  <a:pt x="2" y="4956"/>
-                  <a:pt x="0" y="2434"/>
-                </a:cubicBezTo>
-                <a:lnTo>
-                  <a:pt x="2435" y="2408"/>
-                </a:lnTo>
-                <a:lnTo>
-                  <a:pt x="3056" y="0"/>
-                </a:lnTo>
-                <a:lnTo>
-                  <a:pt x="10000" y="7"/>
-                </a:lnTo>
-                <a:cubicBezTo>
-                  <a:pt x="9999" y="3096"/>
-                  <a:pt x="9997" y="6185"/>
-                  <a:pt x="9996" y="9274"/>
-                </a:cubicBezTo>
-                <a:close/>
-              </a:path>
-            </a:pathLst>
-          </a:custGeom>
-          <a:solidFill>
-            <a:schemeClr val="bg1"/>
-          </a:solidFill>
-          <a:ln w="9525">
-            <a:noFill/>
-            <a:round/>
-          </a:ln>
-          <a:effectLst/>
-        </p:spPr>
-        <p:txBody>
-          <a:bodyPr/>
-          <a:lstStyle/>
-          <a:p>
-            <a:pPr>
-              <a:defRPr/>
-            </a:pPr>
-            <a:endParaRPr lang="zh-CN" altLang="en-US">
-              <a:latin typeface="Arial" panose="020B0604020202020204" pitchFamily="34" charset="0"/>
-            </a:endParaRPr>
-          </a:p>
-        </p:txBody>
-      </p:sp>
-      <p:sp>
-        <p:nvSpPr>
           <p:cNvPr id="6" name="Rectangle 11"/>
           <p:cNvSpPr>
             <a:spLocks noChangeArrowheads="1"/>
@@ -2616,7 +2374,7 @@
           <a:blip r:embed="rId2">
             <a:extLst>
               <a:ext uri="{28A0092B-C50C-407E-A947-70E740481C1C}">
-                <a14:useLocalDpi xmlns:a14="http://schemas.microsoft.com/office/drawing/2010/main" val="0"/>
+                <ns3:useLocalDpi val="0"/>
               </a:ext>
             </a:extLst>
           </a:blip>
@@ -2639,21 +2397,21 @@
           </a:ln>
           <a:extLst>
             <a:ext uri="{909E8E84-426E-40DD-AFC4-6F175D3DCCD1}">
-              <a14:hiddenFill xmlns:a14="http://schemas.microsoft.com/office/drawing/2010/main">
+              <ns3:hiddenFill>
                 <a:solidFill>
                   <a:srgbClr val="FFFFFF"/>
                 </a:solidFill>
-              </a14:hiddenFill>
+              </ns3:hiddenFill>
             </a:ext>
             <a:ext uri="{91240B29-F687-4F45-9708-019B960494DF}">
-              <a14:hiddenLine xmlns:a14="http://schemas.microsoft.com/office/drawing/2010/main" w="9525">
+              <ns3:hiddenLine w="9525">
                 <a:solidFill>
                   <a:srgbClr val="000000"/>
                 </a:solidFill>
                 <a:miter lim="800000"/>
                 <a:headEnd/>
                 <a:tailEnd/>
-              </a14:hiddenLine>
+              </ns3:hiddenLine>
             </a:ext>
           </a:extLst>
         </p:spPr>

</xml_diff>

<commit_message>
fix: enforce consistent ppt table alignment
</commit_message>
<xml_diff>
--- a/assets/templates/inspur-pragmatic-template-v1.pptx
+++ b/assets/templates/inspur-pragmatic-template-v1.pptx
@@ -8859,6 +8859,7 @@
                     <a:bodyPr/>
                     <a:lstStyle/>
                     <a:p>
+                      <a:pPr algn="l"/>
                       <a:r>
                         <a:rPr>
                           <a:latin typeface="Microsoft YaHei"/>
@@ -8876,6 +8877,7 @@
                     <a:bodyPr/>
                     <a:lstStyle/>
                     <a:p>
+                      <a:pPr algn="l"/>
                       <a:r>
                         <a:rPr>
                           <a:latin typeface="Microsoft YaHei"/>
@@ -8886,13 +8888,14 @@
                       </a:r>
                     </a:p>
                   </a:txBody>
-                  <a:tcPr/>
+                  <a:tcPr anchor="ctr"/>
                 </a:tc>
                 <a:tc>
                   <a:txBody>
                     <a:bodyPr/>
                     <a:lstStyle/>
                     <a:p>
+                      <a:pPr algn="l"/>
                       <a:r>
                         <a:rPr>
                           <a:latin typeface="Microsoft YaHei"/>
@@ -8910,6 +8913,7 @@
                     <a:bodyPr/>
                     <a:lstStyle/>
                     <a:p>
+                      <a:pPr algn="l"/>
                       <a:r>
                         <a:rPr>
                           <a:latin typeface="Microsoft YaHei"/>
@@ -8934,6 +8938,7 @@
                     <a:bodyPr/>
                     <a:lstStyle/>
                     <a:p>
+                      <a:pPr algn="l"/>
                       <a:r>
                         <a:rPr>
                           <a:latin typeface="Microsoft YaHei"/>
@@ -8951,6 +8956,7 @@
                     <a:bodyPr/>
                     <a:lstStyle/>
                     <a:p>
+                      <a:pPr algn="l"/>
                       <a:r>
                         <a:rPr>
                           <a:latin typeface="Microsoft YaHei"/>
@@ -8968,6 +8974,7 @@
                     <a:bodyPr/>
                     <a:lstStyle/>
                     <a:p>
+                      <a:pPr algn="l"/>
                       <a:r>
                         <a:rPr>
                           <a:latin typeface="Microsoft YaHei"/>
@@ -8985,6 +8992,7 @@
                     <a:bodyPr/>
                     <a:lstStyle/>
                     <a:p>
+                      <a:pPr algn="l"/>
                       <a:r>
                         <a:rPr>
                           <a:latin typeface="Microsoft YaHei"/>
@@ -9009,6 +9017,7 @@
                     <a:bodyPr/>
                     <a:lstStyle/>
                     <a:p>
+                      <a:pPr algn="l"/>
                       <a:r>
                         <a:rPr>
                           <a:latin typeface="Microsoft YaHei"/>
@@ -9019,13 +9028,14 @@
                       </a:r>
                     </a:p>
                   </a:txBody>
-                  <a:tcPr/>
+                  <a:tcPr anchor="ctr"/>
                 </a:tc>
                 <a:tc>
                   <a:txBody>
                     <a:bodyPr/>
                     <a:lstStyle/>
                     <a:p>
+                      <a:pPr algn="l"/>
                       <a:r>
                         <a:rPr>
                           <a:latin typeface="Microsoft YaHei"/>
@@ -9043,6 +9053,7 @@
                     <a:bodyPr/>
                     <a:lstStyle/>
                     <a:p>
+                      <a:pPr algn="l"/>
                       <a:r>
                         <a:rPr>
                           <a:latin typeface="Microsoft YaHei"/>
@@ -9060,6 +9071,7 @@
                     <a:bodyPr/>
                     <a:lstStyle/>
                     <a:p>
+                      <a:pPr algn="l"/>
                       <a:r>
                         <a:rPr>
                           <a:latin typeface="Microsoft YaHei"/>
@@ -9084,6 +9096,7 @@
                     <a:bodyPr/>
                     <a:lstStyle/>
                     <a:p>
+                      <a:pPr algn="l"/>
                       <a:r>
                         <a:rPr>
                           <a:latin typeface="Microsoft YaHei"/>
@@ -9094,13 +9107,14 @@
                       </a:r>
                     </a:p>
                   </a:txBody>
-                  <a:tcPr/>
+                  <a:tcPr anchor="ctr"/>
                 </a:tc>
                 <a:tc>
                   <a:txBody>
                     <a:bodyPr/>
                     <a:lstStyle/>
                     <a:p>
+                      <a:pPr algn="l"/>
                       <a:r>
                         <a:rPr>
                           <a:latin typeface="Microsoft YaHei"/>
@@ -9118,6 +9132,7 @@
                     <a:bodyPr/>
                     <a:lstStyle/>
                     <a:p>
+                      <a:pPr algn="l"/>
                       <a:r>
                         <a:rPr>
                           <a:latin typeface="Microsoft YaHei"/>
@@ -9135,6 +9150,7 @@
                     <a:bodyPr/>
                     <a:lstStyle/>
                     <a:p>
+                      <a:pPr algn="l"/>
                       <a:r>
                         <a:rPr>
                           <a:latin typeface="Microsoft YaHei"/>
@@ -9159,6 +9175,7 @@
                     <a:bodyPr/>
                     <a:lstStyle/>
                     <a:p>
+                      <a:pPr algn="l"/>
                       <a:r>
                         <a:rPr>
                           <a:latin typeface="Microsoft YaHei"/>
@@ -9176,6 +9193,7 @@
                     <a:bodyPr/>
                     <a:lstStyle/>
                     <a:p>
+                      <a:pPr algn="l"/>
                       <a:r>
                         <a:rPr>
                           <a:latin typeface="Microsoft YaHei"/>
@@ -9193,6 +9211,7 @@
                     <a:bodyPr/>
                     <a:lstStyle/>
                     <a:p>
+                      <a:pPr algn="l"/>
                       <a:r>
                         <a:rPr>
                           <a:latin typeface="Microsoft YaHei"/>
@@ -9210,6 +9229,7 @@
                     <a:bodyPr/>
                     <a:lstStyle/>
                     <a:p>
+                      <a:pPr algn="l"/>
                       <a:r>
                         <a:rPr>
                           <a:latin typeface="Microsoft YaHei"/>
@@ -9234,6 +9254,7 @@
                     <a:bodyPr/>
                     <a:lstStyle/>
                     <a:p>
+                      <a:pPr algn="l"/>
                       <a:r>
                         <a:rPr>
                           <a:latin typeface="Microsoft YaHei"/>
@@ -9244,13 +9265,14 @@
                       </a:r>
                     </a:p>
                   </a:txBody>
-                  <a:tcPr/>
+                  <a:tcPr anchor="ctr"/>
                 </a:tc>
                 <a:tc>
                   <a:txBody>
                     <a:bodyPr/>
                     <a:lstStyle/>
                     <a:p>
+                      <a:pPr algn="l"/>
                       <a:r>
                         <a:rPr>
                           <a:latin typeface="Microsoft YaHei"/>
@@ -9268,6 +9290,7 @@
                     <a:bodyPr/>
                     <a:lstStyle/>
                     <a:p>
+                      <a:pPr algn="l"/>
                       <a:r>
                         <a:rPr>
                           <a:latin typeface="Microsoft YaHei"/>
@@ -9285,6 +9308,7 @@
                     <a:bodyPr/>
                     <a:lstStyle/>
                     <a:p>
+                      <a:pPr algn="l"/>
                       <a:r>
                         <a:rPr>
                           <a:latin typeface="Microsoft YaHei"/>
@@ -9309,6 +9333,7 @@
                     <a:bodyPr/>
                     <a:lstStyle/>
                     <a:p>
+                      <a:pPr algn="l"/>
                       <a:r>
                         <a:rPr>
                           <a:latin typeface="Microsoft YaHei"/>
@@ -9319,13 +9344,14 @@
                       </a:r>
                     </a:p>
                   </a:txBody>
-                  <a:tcPr/>
+                  <a:tcPr anchor="ctr"/>
                 </a:tc>
                 <a:tc>
                   <a:txBody>
                     <a:bodyPr/>
                     <a:lstStyle/>
                     <a:p>
+                      <a:pPr algn="l"/>
                       <a:r>
                         <a:rPr>
                           <a:latin typeface="Microsoft YaHei"/>
@@ -9343,6 +9369,7 @@
                     <a:bodyPr/>
                     <a:lstStyle/>
                     <a:p>
+                      <a:pPr algn="l"/>
                       <a:r>
                         <a:rPr>
                           <a:latin typeface="Microsoft YaHei"/>
@@ -9360,6 +9387,7 @@
                     <a:bodyPr/>
                     <a:lstStyle/>
                     <a:p>
+                      <a:pPr algn="l"/>
                       <a:r>
                         <a:rPr>
                           <a:latin typeface="Microsoft YaHei"/>
@@ -9383,15 +9411,19 @@
                   <a:txBody>
                     <a:bodyPr/>
                     <a:lstStyle/>
-                    <a:p/>
+                    <a:p>
+                      <a:pPr algn="l"/>
+                    </a:p>
                   </a:txBody>
-                  <a:tcPr/>
+                  <a:tcPr anchor="ctr"/>
                 </a:tc>
                 <a:tc>
                   <a:txBody>
                     <a:bodyPr/>
                     <a:lstStyle/>
-                    <a:p/>
+                    <a:p>
+                      <a:pPr algn="l"/>
+                    </a:p>
                   </a:txBody>
                   <a:tcPr marL="8691" marR="8691" marT="8691" marB="0" anchor="ctr"/>
                 </a:tc>
@@ -9399,7 +9431,9 @@
                   <a:txBody>
                     <a:bodyPr/>
                     <a:lstStyle/>
-                    <a:p/>
+                    <a:p>
+                      <a:pPr algn="l"/>
+                    </a:p>
                   </a:txBody>
                   <a:tcPr marL="8691" marR="8691" marT="8691" marB="0" anchor="ctr"/>
                 </a:tc>
@@ -9407,7 +9441,9 @@
                   <a:txBody>
                     <a:bodyPr/>
                     <a:lstStyle/>
-                    <a:p/>
+                    <a:p>
+                      <a:pPr algn="l"/>
+                    </a:p>
                   </a:txBody>
                   <a:tcPr marL="8691" marR="8691" marT="8691" marB="0" anchor="ctr"/>
                 </a:tc>
@@ -9422,15 +9458,19 @@
                   <a:txBody>
                     <a:bodyPr/>
                     <a:lstStyle/>
-                    <a:p/>
+                    <a:p>
+                      <a:pPr algn="l"/>
+                    </a:p>
                   </a:txBody>
-                  <a:tcPr/>
+                  <a:tcPr anchor="ctr"/>
                 </a:tc>
                 <a:tc>
                   <a:txBody>
                     <a:bodyPr/>
                     <a:lstStyle/>
-                    <a:p/>
+                    <a:p>
+                      <a:pPr algn="l"/>
+                    </a:p>
                   </a:txBody>
                   <a:tcPr marL="8691" marR="8691" marT="8691" marB="0" anchor="ctr"/>
                 </a:tc>
@@ -9438,7 +9478,9 @@
                   <a:txBody>
                     <a:bodyPr/>
                     <a:lstStyle/>
-                    <a:p/>
+                    <a:p>
+                      <a:pPr algn="l"/>
+                    </a:p>
                   </a:txBody>
                   <a:tcPr marL="8691" marR="8691" marT="8691" marB="0" anchor="ctr"/>
                 </a:tc>
@@ -9446,7 +9488,9 @@
                   <a:txBody>
                     <a:bodyPr/>
                     <a:lstStyle/>
-                    <a:p/>
+                    <a:p>
+                      <a:pPr algn="l"/>
+                    </a:p>
                   </a:txBody>
                   <a:tcPr marL="8691" marR="8691" marT="8691" marB="0" anchor="ctr"/>
                 </a:tc>
@@ -9461,15 +9505,19 @@
                   <a:txBody>
                     <a:bodyPr/>
                     <a:lstStyle/>
-                    <a:p/>
+                    <a:p>
+                      <a:pPr algn="l"/>
+                    </a:p>
                   </a:txBody>
-                  <a:tcPr/>
+                  <a:tcPr anchor="ctr"/>
                 </a:tc>
                 <a:tc>
                   <a:txBody>
                     <a:bodyPr/>
                     <a:lstStyle/>
-                    <a:p/>
+                    <a:p>
+                      <a:pPr algn="l"/>
+                    </a:p>
                   </a:txBody>
                   <a:tcPr marL="8691" marR="8691" marT="8691" marB="0" anchor="ctr"/>
                 </a:tc>
@@ -9477,7 +9525,9 @@
                   <a:txBody>
                     <a:bodyPr/>
                     <a:lstStyle/>
-                    <a:p/>
+                    <a:p>
+                      <a:pPr algn="l"/>
+                    </a:p>
                   </a:txBody>
                   <a:tcPr marL="8691" marR="8691" marT="8691" marB="0" anchor="ctr"/>
                 </a:tc>
@@ -9485,7 +9535,9 @@
                   <a:txBody>
                     <a:bodyPr/>
                     <a:lstStyle/>
-                    <a:p/>
+                    <a:p>
+                      <a:pPr algn="l"/>
+                    </a:p>
                   </a:txBody>
                   <a:tcPr marL="8691" marR="8691" marT="8691" marB="0" anchor="ctr"/>
                 </a:tc>
@@ -9500,15 +9552,19 @@
                   <a:txBody>
                     <a:bodyPr/>
                     <a:lstStyle/>
-                    <a:p/>
+                    <a:p>
+                      <a:pPr algn="l"/>
+                    </a:p>
                   </a:txBody>
-                  <a:tcPr/>
+                  <a:tcPr anchor="ctr"/>
                 </a:tc>
                 <a:tc>
                   <a:txBody>
                     <a:bodyPr/>
                     <a:lstStyle/>
-                    <a:p/>
+                    <a:p>
+                      <a:pPr algn="l"/>
+                    </a:p>
                   </a:txBody>
                   <a:tcPr marL="8691" marR="8691" marT="8691" marB="0" anchor="ctr"/>
                 </a:tc>
@@ -9516,7 +9572,9 @@
                   <a:txBody>
                     <a:bodyPr/>
                     <a:lstStyle/>
-                    <a:p/>
+                    <a:p>
+                      <a:pPr algn="l"/>
+                    </a:p>
                   </a:txBody>
                   <a:tcPr marL="8691" marR="8691" marT="8691" marB="0" anchor="ctr"/>
                 </a:tc>
@@ -9524,7 +9582,9 @@
                   <a:txBody>
                     <a:bodyPr/>
                     <a:lstStyle/>
-                    <a:p/>
+                    <a:p>
+                      <a:pPr algn="l"/>
+                    </a:p>
                   </a:txBody>
                   <a:tcPr marL="8691" marR="8691" marT="8691" marB="0" anchor="ctr"/>
                 </a:tc>
@@ -9539,7 +9599,9 @@
                   <a:txBody>
                     <a:bodyPr/>
                     <a:lstStyle/>
-                    <a:p/>
+                    <a:p>
+                      <a:pPr algn="l"/>
+                    </a:p>
                   </a:txBody>
                   <a:tcPr marL="8691" marR="8691" marT="8691" marB="0" anchor="ctr"/>
                 </a:tc>
@@ -9547,7 +9609,9 @@
                   <a:txBody>
                     <a:bodyPr/>
                     <a:lstStyle/>
-                    <a:p/>
+                    <a:p>
+                      <a:pPr algn="l"/>
+                    </a:p>
                   </a:txBody>
                   <a:tcPr marL="8691" marR="8691" marT="8691" marB="0" anchor="ctr"/>
                 </a:tc>
@@ -9555,7 +9619,9 @@
                   <a:txBody>
                     <a:bodyPr/>
                     <a:lstStyle/>
-                    <a:p/>
+                    <a:p>
+                      <a:pPr algn="l"/>
+                    </a:p>
                   </a:txBody>
                   <a:tcPr marL="8691" marR="8691" marT="8691" marB="0" anchor="ctr"/>
                 </a:tc>
@@ -9563,7 +9629,9 @@
                   <a:txBody>
                     <a:bodyPr/>
                     <a:lstStyle/>
-                    <a:p/>
+                    <a:p>
+                      <a:pPr algn="l"/>
+                    </a:p>
                   </a:txBody>
                   <a:tcPr marL="8691" marR="8691" marT="8691" marB="0" anchor="ctr"/>
                 </a:tc>
@@ -9578,15 +9646,19 @@
                   <a:txBody>
                     <a:bodyPr/>
                     <a:lstStyle/>
-                    <a:p/>
+                    <a:p>
+                      <a:pPr algn="l"/>
+                    </a:p>
                   </a:txBody>
-                  <a:tcPr/>
+                  <a:tcPr anchor="ctr"/>
                 </a:tc>
                 <a:tc>
                   <a:txBody>
                     <a:bodyPr/>
                     <a:lstStyle/>
-                    <a:p/>
+                    <a:p>
+                      <a:pPr algn="l"/>
+                    </a:p>
                   </a:txBody>
                   <a:tcPr marL="8691" marR="8691" marT="8691" marB="0" anchor="ctr"/>
                 </a:tc>
@@ -9594,7 +9666,9 @@
                   <a:txBody>
                     <a:bodyPr/>
                     <a:lstStyle/>
-                    <a:p/>
+                    <a:p>
+                      <a:pPr algn="l"/>
+                    </a:p>
                   </a:txBody>
                   <a:tcPr marL="8691" marR="8691" marT="8691" marB="0" anchor="ctr"/>
                 </a:tc>
@@ -9602,7 +9676,9 @@
                   <a:txBody>
                     <a:bodyPr/>
                     <a:lstStyle/>
-                    <a:p/>
+                    <a:p>
+                      <a:pPr algn="l"/>
+                    </a:p>
                   </a:txBody>
                   <a:tcPr marL="8691" marR="8691" marT="8691" marB="0" anchor="ctr"/>
                 </a:tc>
@@ -9617,15 +9693,19 @@
                   <a:txBody>
                     <a:bodyPr/>
                     <a:lstStyle/>
-                    <a:p/>
+                    <a:p>
+                      <a:pPr algn="l"/>
+                    </a:p>
                   </a:txBody>
-                  <a:tcPr/>
+                  <a:tcPr anchor="ctr"/>
                 </a:tc>
                 <a:tc>
                   <a:txBody>
                     <a:bodyPr/>
                     <a:lstStyle/>
-                    <a:p/>
+                    <a:p>
+                      <a:pPr algn="l"/>
+                    </a:p>
                   </a:txBody>
                   <a:tcPr marL="8691" marR="8691" marT="8691" marB="0" anchor="ctr"/>
                 </a:tc>
@@ -9633,7 +9713,9 @@
                   <a:txBody>
                     <a:bodyPr/>
                     <a:lstStyle/>
-                    <a:p/>
+                    <a:p>
+                      <a:pPr algn="l"/>
+                    </a:p>
                   </a:txBody>
                   <a:tcPr marL="8691" marR="8691" marT="8691" marB="0" anchor="ctr"/>
                 </a:tc>
@@ -9641,7 +9723,9 @@
                   <a:txBody>
                     <a:bodyPr/>
                     <a:lstStyle/>
-                    <a:p/>
+                    <a:p>
+                      <a:pPr algn="l"/>
+                    </a:p>
                   </a:txBody>
                   <a:tcPr marL="8691" marR="8691" marT="8691" marB="0" anchor="ctr"/>
                 </a:tc>
@@ -9656,15 +9740,19 @@
                   <a:txBody>
                     <a:bodyPr/>
                     <a:lstStyle/>
-                    <a:p/>
+                    <a:p>
+                      <a:pPr algn="l"/>
+                    </a:p>
                   </a:txBody>
-                  <a:tcPr/>
+                  <a:tcPr anchor="ctr"/>
                 </a:tc>
                 <a:tc>
                   <a:txBody>
                     <a:bodyPr/>
                     <a:lstStyle/>
-                    <a:p/>
+                    <a:p>
+                      <a:pPr algn="l"/>
+                    </a:p>
                   </a:txBody>
                   <a:tcPr marL="8691" marR="8691" marT="8691" marB="0" anchor="ctr"/>
                 </a:tc>
@@ -9672,7 +9760,9 @@
                   <a:txBody>
                     <a:bodyPr/>
                     <a:lstStyle/>
-                    <a:p/>
+                    <a:p>
+                      <a:pPr algn="l"/>
+                    </a:p>
                   </a:txBody>
                   <a:tcPr marL="8691" marR="8691" marT="8691" marB="0" anchor="ctr"/>
                 </a:tc>
@@ -9680,7 +9770,9 @@
                   <a:txBody>
                     <a:bodyPr/>
                     <a:lstStyle/>
-                    <a:p/>
+                    <a:p>
+                      <a:pPr algn="l"/>
+                    </a:p>
                   </a:txBody>
                   <a:tcPr marL="8691" marR="8691" marT="8691" marB="0" anchor="ctr"/>
                 </a:tc>
@@ -9695,15 +9787,19 @@
                   <a:txBody>
                     <a:bodyPr/>
                     <a:lstStyle/>
-                    <a:p/>
+                    <a:p>
+                      <a:pPr algn="l"/>
+                    </a:p>
                   </a:txBody>
-                  <a:tcPr/>
+                  <a:tcPr anchor="ctr"/>
                 </a:tc>
                 <a:tc>
                   <a:txBody>
                     <a:bodyPr/>
                     <a:lstStyle/>
-                    <a:p/>
+                    <a:p>
+                      <a:pPr algn="l"/>
+                    </a:p>
                   </a:txBody>
                   <a:tcPr marL="8691" marR="8691" marT="8691" marB="0" anchor="ctr"/>
                 </a:tc>
@@ -9711,7 +9807,9 @@
                   <a:txBody>
                     <a:bodyPr/>
                     <a:lstStyle/>
-                    <a:p/>
+                    <a:p>
+                      <a:pPr algn="l"/>
+                    </a:p>
                   </a:txBody>
                   <a:tcPr marL="8691" marR="8691" marT="8691" marB="0" anchor="ctr"/>
                 </a:tc>
@@ -9719,7 +9817,9 @@
                   <a:txBody>
                     <a:bodyPr/>
                     <a:lstStyle/>
-                    <a:p/>
+                    <a:p>
+                      <a:pPr algn="l"/>
+                    </a:p>
                   </a:txBody>
                   <a:tcPr marL="8691" marR="8691" marT="8691" marB="0" anchor="ctr"/>
                 </a:tc>
@@ -9734,7 +9834,9 @@
                   <a:txBody>
                     <a:bodyPr/>
                     <a:lstStyle/>
-                    <a:p/>
+                    <a:p>
+                      <a:pPr algn="l"/>
+                    </a:p>
                   </a:txBody>
                   <a:tcPr marL="8691" marR="8691" marT="8691" marB="0" anchor="ctr"/>
                 </a:tc>
@@ -9742,7 +9844,9 @@
                   <a:txBody>
                     <a:bodyPr/>
                     <a:lstStyle/>
-                    <a:p/>
+                    <a:p>
+                      <a:pPr algn="l"/>
+                    </a:p>
                   </a:txBody>
                   <a:tcPr marL="8691" marR="8691" marT="8691" marB="0" anchor="ctr"/>
                 </a:tc>
@@ -9750,7 +9854,9 @@
                   <a:txBody>
                     <a:bodyPr/>
                     <a:lstStyle/>
-                    <a:p/>
+                    <a:p>
+                      <a:pPr algn="l"/>
+                    </a:p>
                   </a:txBody>
                   <a:tcPr marL="8691" marR="8691" marT="8691" marB="0" anchor="ctr"/>
                 </a:tc>
@@ -9758,7 +9864,9 @@
                   <a:txBody>
                     <a:bodyPr/>
                     <a:lstStyle/>
-                    <a:p/>
+                    <a:p>
+                      <a:pPr algn="l"/>
+                    </a:p>
                   </a:txBody>
                   <a:tcPr marL="8691" marR="8691" marT="8691" marB="0" anchor="ctr"/>
                 </a:tc>
@@ -9773,15 +9881,19 @@
                   <a:txBody>
                     <a:bodyPr/>
                     <a:lstStyle/>
-                    <a:p/>
+                    <a:p>
+                      <a:pPr algn="l"/>
+                    </a:p>
                   </a:txBody>
-                  <a:tcPr/>
+                  <a:tcPr anchor="ctr"/>
                 </a:tc>
                 <a:tc>
                   <a:txBody>
                     <a:bodyPr/>
                     <a:lstStyle/>
-                    <a:p/>
+                    <a:p>
+                      <a:pPr algn="l"/>
+                    </a:p>
                   </a:txBody>
                   <a:tcPr marL="8691" marR="8691" marT="8691" marB="0" anchor="ctr"/>
                 </a:tc>
@@ -9789,7 +9901,9 @@
                   <a:txBody>
                     <a:bodyPr/>
                     <a:lstStyle/>
-                    <a:p/>
+                    <a:p>
+                      <a:pPr algn="l"/>
+                    </a:p>
                   </a:txBody>
                   <a:tcPr marL="8691" marR="8691" marT="8691" marB="0" anchor="ctr"/>
                 </a:tc>
@@ -9797,7 +9911,9 @@
                   <a:txBody>
                     <a:bodyPr/>
                     <a:lstStyle/>
-                    <a:p/>
+                    <a:p>
+                      <a:pPr algn="l"/>
+                    </a:p>
                   </a:txBody>
                   <a:tcPr marL="8691" marR="8691" marT="8691" marB="0" anchor="ctr"/>
                 </a:tc>
@@ -9812,15 +9928,19 @@
                   <a:txBody>
                     <a:bodyPr/>
                     <a:lstStyle/>
-                    <a:p/>
+                    <a:p>
+                      <a:pPr algn="l"/>
+                    </a:p>
                   </a:txBody>
-                  <a:tcPr/>
+                  <a:tcPr anchor="ctr"/>
                 </a:tc>
                 <a:tc>
                   <a:txBody>
                     <a:bodyPr/>
                     <a:lstStyle/>
-                    <a:p/>
+                    <a:p>
+                      <a:pPr algn="l"/>
+                    </a:p>
                   </a:txBody>
                   <a:tcPr marL="8691" marR="8691" marT="8691" marB="0" anchor="ctr"/>
                 </a:tc>
@@ -9828,7 +9948,9 @@
                   <a:txBody>
                     <a:bodyPr/>
                     <a:lstStyle/>
-                    <a:p/>
+                    <a:p>
+                      <a:pPr algn="l"/>
+                    </a:p>
                   </a:txBody>
                   <a:tcPr marL="8691" marR="8691" marT="8691" marB="0" anchor="ctr"/>
                 </a:tc>
@@ -9836,7 +9958,9 @@
                   <a:txBody>
                     <a:bodyPr/>
                     <a:lstStyle/>
-                    <a:p/>
+                    <a:p>
+                      <a:pPr algn="l"/>
+                    </a:p>
                   </a:txBody>
                   <a:tcPr marL="8691" marR="8691" marT="8691" marB="0" anchor="ctr"/>
                 </a:tc>
@@ -9851,15 +9975,19 @@
                   <a:txBody>
                     <a:bodyPr/>
                     <a:lstStyle/>
-                    <a:p/>
+                    <a:p>
+                      <a:pPr algn="l"/>
+                    </a:p>
                   </a:txBody>
-                  <a:tcPr/>
+                  <a:tcPr anchor="ctr"/>
                 </a:tc>
                 <a:tc>
                   <a:txBody>
                     <a:bodyPr/>
                     <a:lstStyle/>
-                    <a:p/>
+                    <a:p>
+                      <a:pPr algn="l"/>
+                    </a:p>
                   </a:txBody>
                   <a:tcPr marL="8691" marR="8691" marT="8691" marB="0" anchor="ctr"/>
                 </a:tc>
@@ -9867,7 +9995,9 @@
                   <a:txBody>
                     <a:bodyPr/>
                     <a:lstStyle/>
-                    <a:p/>
+                    <a:p>
+                      <a:pPr algn="l"/>
+                    </a:p>
                   </a:txBody>
                   <a:tcPr marL="8691" marR="8691" marT="8691" marB="0" anchor="ctr"/>
                 </a:tc>
@@ -9875,7 +10005,9 @@
                   <a:txBody>
                     <a:bodyPr/>
                     <a:lstStyle/>
-                    <a:p/>
+                    <a:p>
+                      <a:pPr algn="l"/>
+                    </a:p>
                   </a:txBody>
                   <a:tcPr marL="8691" marR="8691" marT="8691" marB="0" anchor="ctr"/>
                 </a:tc>
@@ -9890,7 +10022,9 @@
                   <a:txBody>
                     <a:bodyPr/>
                     <a:lstStyle/>
-                    <a:p/>
+                    <a:p>
+                      <a:pPr algn="l"/>
+                    </a:p>
                   </a:txBody>
                   <a:tcPr marL="8691" marR="8691" marT="8691" marB="0" anchor="ctr"/>
                 </a:tc>
@@ -9898,7 +10032,9 @@
                   <a:txBody>
                     <a:bodyPr/>
                     <a:lstStyle/>
-                    <a:p/>
+                    <a:p>
+                      <a:pPr algn="l"/>
+                    </a:p>
                   </a:txBody>
                   <a:tcPr marL="8691" marR="8691" marT="8691" marB="0" anchor="ctr"/>
                 </a:tc>
@@ -9906,7 +10042,9 @@
                   <a:txBody>
                     <a:bodyPr/>
                     <a:lstStyle/>
-                    <a:p/>
+                    <a:p>
+                      <a:pPr algn="l"/>
+                    </a:p>
                   </a:txBody>
                   <a:tcPr marL="8691" marR="8691" marT="8691" marB="0" anchor="ctr"/>
                 </a:tc>
@@ -9914,7 +10052,9 @@
                   <a:txBody>
                     <a:bodyPr/>
                     <a:lstStyle/>
-                    <a:p/>
+                    <a:p>
+                      <a:pPr algn="l"/>
+                    </a:p>
                   </a:txBody>
                   <a:tcPr marL="8691" marR="8691" marT="8691" marB="0" anchor="ctr"/>
                 </a:tc>
@@ -9929,15 +10069,19 @@
                   <a:txBody>
                     <a:bodyPr/>
                     <a:lstStyle/>
-                    <a:p/>
+                    <a:p>
+                      <a:pPr algn="l"/>
+                    </a:p>
                   </a:txBody>
-                  <a:tcPr/>
+                  <a:tcPr anchor="ctr"/>
                 </a:tc>
                 <a:tc>
                   <a:txBody>
                     <a:bodyPr/>
                     <a:lstStyle/>
-                    <a:p/>
+                    <a:p>
+                      <a:pPr algn="l"/>
+                    </a:p>
                   </a:txBody>
                   <a:tcPr marL="8691" marR="8691" marT="8691" marB="0" anchor="ctr"/>
                 </a:tc>
@@ -9945,7 +10089,9 @@
                   <a:txBody>
                     <a:bodyPr/>
                     <a:lstStyle/>
-                    <a:p/>
+                    <a:p>
+                      <a:pPr algn="l"/>
+                    </a:p>
                   </a:txBody>
                   <a:tcPr marL="8691" marR="8691" marT="8691" marB="0" anchor="ctr"/>
                 </a:tc>
@@ -9953,7 +10099,9 @@
                   <a:txBody>
                     <a:bodyPr/>
                     <a:lstStyle/>
-                    <a:p/>
+                    <a:p>
+                      <a:pPr algn="l"/>
+                    </a:p>
                   </a:txBody>
                   <a:tcPr marL="8691" marR="8691" marT="8691" marB="0" anchor="ctr"/>
                 </a:tc>
@@ -9968,15 +10116,19 @@
                   <a:txBody>
                     <a:bodyPr/>
                     <a:lstStyle/>
-                    <a:p/>
+                    <a:p>
+                      <a:pPr algn="l"/>
+                    </a:p>
                   </a:txBody>
-                  <a:tcPr/>
+                  <a:tcPr anchor="ctr"/>
                 </a:tc>
                 <a:tc>
                   <a:txBody>
                     <a:bodyPr/>
                     <a:lstStyle/>
-                    <a:p/>
+                    <a:p>
+                      <a:pPr algn="l"/>
+                    </a:p>
                   </a:txBody>
                   <a:tcPr marL="8691" marR="8691" marT="8691" marB="0" anchor="ctr"/>
                 </a:tc>
@@ -9984,7 +10136,9 @@
                   <a:txBody>
                     <a:bodyPr/>
                     <a:lstStyle/>
-                    <a:p/>
+                    <a:p>
+                      <a:pPr algn="l"/>
+                    </a:p>
                   </a:txBody>
                   <a:tcPr marL="8691" marR="8691" marT="8691" marB="0" anchor="ctr"/>
                 </a:tc>
@@ -9992,7 +10146,9 @@
                   <a:txBody>
                     <a:bodyPr/>
                     <a:lstStyle/>
-                    <a:p/>
+                    <a:p>
+                      <a:pPr algn="l"/>
+                    </a:p>
                   </a:txBody>
                   <a:tcPr marL="8691" marR="8691" marT="8691" marB="0" anchor="ctr"/>
                 </a:tc>
@@ -10007,15 +10163,19 @@
                   <a:txBody>
                     <a:bodyPr/>
                     <a:lstStyle/>
-                    <a:p/>
+                    <a:p>
+                      <a:pPr algn="l"/>
+                    </a:p>
                   </a:txBody>
-                  <a:tcPr/>
+                  <a:tcPr anchor="ctr"/>
                 </a:tc>
                 <a:tc>
                   <a:txBody>
                     <a:bodyPr/>
                     <a:lstStyle/>
-                    <a:p/>
+                    <a:p>
+                      <a:pPr algn="l"/>
+                    </a:p>
                   </a:txBody>
                   <a:tcPr marL="8691" marR="8691" marT="8691" marB="0" anchor="ctr"/>
                 </a:tc>
@@ -10023,7 +10183,9 @@
                   <a:txBody>
                     <a:bodyPr/>
                     <a:lstStyle/>
-                    <a:p/>
+                    <a:p>
+                      <a:pPr algn="l"/>
+                    </a:p>
                   </a:txBody>
                   <a:tcPr marL="8691" marR="8691" marT="8691" marB="0" anchor="ctr"/>
                 </a:tc>
@@ -10031,7 +10193,9 @@
                   <a:txBody>
                     <a:bodyPr/>
                     <a:lstStyle/>
-                    <a:p/>
+                    <a:p>
+                      <a:pPr algn="l"/>
+                    </a:p>
                   </a:txBody>
                   <a:tcPr marL="8691" marR="8691" marT="8691" marB="0" anchor="ctr"/>
                 </a:tc>
@@ -10046,15 +10210,19 @@
                   <a:txBody>
                     <a:bodyPr/>
                     <a:lstStyle/>
-                    <a:p/>
+                    <a:p>
+                      <a:pPr algn="l"/>
+                    </a:p>
                   </a:txBody>
-                  <a:tcPr/>
+                  <a:tcPr anchor="ctr"/>
                 </a:tc>
                 <a:tc>
                   <a:txBody>
                     <a:bodyPr/>
                     <a:lstStyle/>
-                    <a:p/>
+                    <a:p>
+                      <a:pPr algn="l"/>
+                    </a:p>
                   </a:txBody>
                   <a:tcPr marL="8691" marR="8691" marT="8691" marB="0" anchor="ctr"/>
                 </a:tc>
@@ -10062,7 +10230,9 @@
                   <a:txBody>
                     <a:bodyPr/>
                     <a:lstStyle/>
-                    <a:p/>
+                    <a:p>
+                      <a:pPr algn="l"/>
+                    </a:p>
                   </a:txBody>
                   <a:tcPr marL="8691" marR="8691" marT="8691" marB="0" anchor="ctr"/>
                 </a:tc>
@@ -10070,7 +10240,9 @@
                   <a:txBody>
                     <a:bodyPr/>
                     <a:lstStyle/>
-                    <a:p/>
+                    <a:p>
+                      <a:pPr algn="l"/>
+                    </a:p>
                   </a:txBody>
                   <a:tcPr marL="8691" marR="8691" marT="8691" marB="0" anchor="ctr"/>
                 </a:tc>

</xml_diff>

<commit_message>
fix: clean ppt title placeholders
</commit_message>
<xml_diff>
--- a/assets/templates/inspur-pragmatic-template-v1.pptx
+++ b/assets/templates/inspur-pragmatic-template-v1.pptx
@@ -8183,11 +8183,11 @@
           <a:p>
             <a:pPr lvl="0" algn="l" eaLnBrk="1" hangingPunct="1"/>
             <a:r>
-              <a:rPr sz="2400" b="0">
+              <a:rPr sz="3800" b="1">
                 <a:solidFill>
                   <a:srgbClr val="0062AC"/>
                 </a:solidFill>
-                <a:latin typeface="Microsoft YaHei"/>
+                <a:latin typeface="微软雅黑"/>
                 <a:ea typeface="微软雅黑"/>
                 <a:cs typeface="Microsoft YaHei"/>
               </a:rPr>
@@ -8236,40 +8236,6 @@
           <a:chExt cx="0" cy="0"/>
         </a:xfrm>
       </ns0:grpSpPr>
-      <ns0:sp>
-        <ns0:nvSpPr>
-          <ns0:cNvPr id="5122" name="标题 1"/>
-          <ns0:cNvSpPr>
-            <a:spLocks noGrp="1"/>
-          </ns0:cNvSpPr>
-          <ns0:nvPr>
-            <ns0:ph type="title"/>
-          </ns0:nvPr>
-        </ns0:nvSpPr>
-        <ns0:spPr>
-          <a:xfrm>
-            <a:off x="371019" y="0"/>
-            <a:ext cx="8640763" cy="836613"/>
-          </a:xfrm>
-        </ns0:spPr>
-        <ns0:txBody>
-          <a:bodyPr/>
-          <a:lstStyle/>
-          <a:p>
-            <a:r>
-              <a:rPr sz="2000" b="0">
-                <a:solidFill>
-                  <a:srgbClr val="FFFFFF"/>
-                </a:solidFill>
-                <a:latin typeface="Microsoft YaHei"/>
-                <a:ea typeface="微软雅黑"/>
-                <a:cs typeface="Microsoft YaHei"/>
-              </a:rPr>
-              <a:t>章节标题</a:t>
-            </a:r>
-          </a:p>
-        </ns0:txBody>
-      </ns0:sp>
       <ns0:grpSp>
         <ns0:nvGrpSpPr>
           <ns0:cNvPr id="4" name="组合 3"/>
@@ -8553,11 +8519,11 @@
           <a:lstStyle/>
           <a:p>
             <a:r>
-              <a:rPr sz="2000" b="0">
+              <a:rPr sz="2600" b="1">
                 <a:solidFill>
                   <a:srgbClr val="FFFFFF"/>
                 </a:solidFill>
-                <a:latin typeface="Microsoft YaHei"/>
+                <a:latin typeface="微软雅黑"/>
                 <a:ea typeface="微软雅黑"/>
                 <a:cs typeface="Microsoft YaHei"/>
               </a:rPr>
@@ -8614,11 +8580,11 @@
           <a:lstStyle/>
           <a:p>
             <a:r>
-              <a:rPr sz="1800" b="0">
+              <a:rPr sz="2800" b="1">
                 <a:solidFill>
                   <a:srgbClr val="202020"/>
                 </a:solidFill>
-                <a:latin typeface="Microsoft YaHei"/>
+                <a:latin typeface="微软雅黑"/>
                 <a:ea typeface="微软雅黑"/>
                 <a:cs typeface="Microsoft YaHei"/>
               </a:rPr>
@@ -8781,11 +8747,11 @@
           <a:lstStyle/>
           <a:p>
             <a:r>
-              <a:rPr sz="1800" b="0">
+              <a:rPr sz="2800" b="1">
                 <a:solidFill>
                   <a:srgbClr val="202020"/>
                 </a:solidFill>
-                <a:latin typeface="Microsoft YaHei"/>
+                <a:latin typeface="微软雅黑"/>
                 <a:ea typeface="微软雅黑"/>
                 <a:cs typeface="Microsoft YaHei"/>
               </a:rPr>
@@ -10297,11 +10263,11 @@
           <a:lstStyle/>
           <a:p>
             <a:r>
-              <a:rPr sz="1800" b="0">
+              <a:rPr sz="2800" b="1">
                 <a:solidFill>
                   <a:srgbClr val="202020"/>
                 </a:solidFill>
-                <a:latin typeface="Microsoft YaHei"/>
+                <a:latin typeface="微软雅黑"/>
                 <a:ea typeface="微软雅黑"/>
                 <a:cs typeface="Microsoft YaHei"/>
               </a:rPr>
@@ -10509,11 +10475,11 @@
           <a:lstStyle/>
           <a:p>
             <a:r>
-              <a:rPr sz="1800" b="0">
+              <a:rPr sz="2800" b="1">
                 <a:solidFill>
                   <a:srgbClr val="202020"/>
                 </a:solidFill>
-                <a:latin typeface="Microsoft YaHei"/>
+                <a:latin typeface="微软雅黑"/>
                 <a:ea typeface="微软雅黑"/>
                 <a:cs typeface="Microsoft YaHei"/>
               </a:rPr>
@@ -10620,11 +10586,11 @@
           <a:lstStyle/>
           <a:p>
             <a:r>
-              <a:rPr sz="1800" b="0">
+              <a:rPr sz="2800" b="1">
                 <a:solidFill>
                   <a:srgbClr val="202020"/>
                 </a:solidFill>
-                <a:latin typeface="Microsoft YaHei"/>
+                <a:latin typeface="微软雅黑"/>
                 <a:ea typeface="微软雅黑"/>
                 <a:cs typeface="Microsoft YaHei"/>
               </a:rPr>

</xml_diff>

<commit_message>
feat: update cover template to white body
</commit_message>
<xml_diff>
--- a/assets/templates/inspur-pragmatic-template-v1.pptx
+++ b/assets/templates/inspur-pragmatic-template-v1.pptx
@@ -8094,47 +8094,59 @@
       <p:grpSpPr/>
       <p:sp>
         <p:nvSpPr>
-          <p:cNvPr id="2" name="Subtitle 1"/>
-          <p:cNvSpPr>
-            <a:spLocks noGrp="1"/>
-          </p:cNvSpPr>
-          <p:nvPr>
-            <p:ph type="subTitle" idx="1"/>
-          </p:nvPr>
+          <p:cNvPr id="2" name="Cover White Body Background"/>
+          <p:cNvSpPr/>
+          <p:nvPr/>
+        </p:nvSpPr>
+        <p:spPr>
+          <a:xfrm>
+            <a:off x="0" y="1591056"/>
+            <a:ext cx="12191695" cy="3822191"/>
+          </a:xfrm>
+          <a:prstGeom prst="rect">
+            <a:avLst/>
+          </a:prstGeom>
+          <a:solidFill>
+            <a:srgbClr val="FFFFFF"/>
+          </a:solidFill>
+          <a:ln>
+            <a:solidFill>
+              <a:srgbClr val="FFFFFF"/>
+            </a:solidFill>
+          </a:ln>
+        </p:spPr>
+        <p:style>
+          <a:lnRef idx="1">
+            <a:schemeClr val="accent1"/>
+          </a:lnRef>
+          <a:fillRef idx="3">
+            <a:schemeClr val="accent1"/>
+          </a:fillRef>
+          <a:effectRef idx="2">
+            <a:schemeClr val="accent1"/>
+          </a:effectRef>
+          <a:fontRef idx="minor">
+            <a:schemeClr val="lt1"/>
+          </a:fontRef>
+        </p:style>
+        <p:txBody>
+          <a:bodyPr rtlCol="0" anchor="ctr"/>
+          <a:lstStyle/>
+          <a:p>
+            <a:pPr algn="ctr"/>
+          </a:p>
+        </p:txBody>
+      </p:sp>
+      <p:sp>
+        <p:nvSpPr>
+          <p:cNvPr id="3" name="TextBox 2"/>
+          <p:cNvSpPr txBox="1"/>
+          <p:nvPr/>
         </p:nvSpPr>
         <p:spPr>
           <a:xfrm>
             <a:off x="2103120" y="2633472"/>
             <a:ext cx="7955279" cy="640080"/>
-          </a:xfrm>
-        </p:spPr>
-        <p:txBody>
-          <a:bodyPr wrap="square" lIns="0" rIns="0" tIns="0" bIns="0" anchor="ctr"/>
-          <a:lstStyle/>
-          <a:p>
-            <a:pPr algn="ctr"/>
-            <a:r>
-              <a:rPr sz="3000" b="1">
-                <a:solidFill>
-                  <a:srgbClr val="213261"/>
-                </a:solidFill>
-                <a:latin typeface="Microsoft YaHei"/>
-              </a:rPr>
-              <a:t>技术方案评审材料</a:t>
-            </a:r>
-          </a:p>
-        </p:txBody>
-      </p:sp>
-      <p:sp>
-        <p:nvSpPr>
-          <p:cNvPr id="3" name="TextBox 2"/>
-          <p:cNvSpPr txBox="1"/>
-          <p:nvPr/>
-        </p:nvSpPr>
-        <p:spPr>
-          <a:xfrm>
-            <a:off x="2331720" y="3310128"/>
-            <a:ext cx="7498079" cy="329184"/>
           </a:xfrm>
           <a:prstGeom prst="rect">
             <a:avLst/>
@@ -8149,6 +8161,41 @@
           <a:p>
             <a:pPr algn="ctr"/>
             <a:r>
+              <a:rPr sz="3000" b="1">
+                <a:solidFill>
+                  <a:srgbClr val="213261"/>
+                </a:solidFill>
+                <a:latin typeface="Microsoft YaHei"/>
+              </a:rPr>
+              <a:t>技术方案评审材料</a:t>
+            </a:r>
+          </a:p>
+        </p:txBody>
+      </p:sp>
+      <p:sp>
+        <p:nvSpPr>
+          <p:cNvPr id="4" name="TextBox 3"/>
+          <p:cNvSpPr txBox="1"/>
+          <p:nvPr/>
+        </p:nvSpPr>
+        <p:spPr>
+          <a:xfrm>
+            <a:off x="2331720" y="3310128"/>
+            <a:ext cx="7498079" cy="329184"/>
+          </a:xfrm>
+          <a:prstGeom prst="rect">
+            <a:avLst/>
+          </a:prstGeom>
+          <a:noFill/>
+        </p:spPr>
+        <p:txBody>
+          <a:bodyPr wrap="square" lIns="0" rIns="0" tIns="0" bIns="0" anchor="ctr">
+            <a:spAutoFit/>
+          </a:bodyPr>
+          <a:lstStyle/>
+          <a:p>
+            <a:pPr algn="ctr"/>
+            <a:r>
               <a:rPr sz="1500" b="0">
                 <a:solidFill>
                   <a:srgbClr val="111111"/>
@@ -8162,7 +8209,7 @@
       </p:sp>
       <p:sp>
         <p:nvSpPr>
-          <p:cNvPr id="4" name="TextBox 3"/>
+          <p:cNvPr id="5" name="TextBox 4"/>
           <p:cNvSpPr txBox="1"/>
           <p:nvPr/>
         </p:nvSpPr>
@@ -8197,7 +8244,7 @@
       </p:sp>
       <p:sp>
         <p:nvSpPr>
-          <p:cNvPr id="5" name="TextBox 4"/>
+          <p:cNvPr id="6" name="TextBox 5"/>
           <p:cNvSpPr txBox="1"/>
           <p:nvPr/>
         </p:nvSpPr>

</xml_diff>